<commit_message>
feat: SEG-01 + SEG-02 QA verified - v0.22.0
</commit_message>
<xml_diff>
--- a/Do-Do-Founders-Deck.pptx
+++ b/Do-Do-Founders-Deck.pptx
@@ -14745,6 +14745,10 @@
             <a:prstDash val="solid"/>
           </a:ln>
         </p:spPr>
+        <p:txBody>
+          <a:bodyPr/>
+          <a:p/>
+        </p:txBody>
       </p:sp>
       <p:sp>
         <p:nvSpPr>
@@ -14815,7 +14819,7 @@
                 <a:ea typeface="Calibri" pitchFamily="34" charset="-122"/>
                 <a:cs typeface="Calibri" pitchFamily="34" charset="-120"/>
               </a:rPr>
-              <a:t>Six modules - one shared space</a:t>
+              <a:t>Eight modules - one shared space</a:t>
             </a:r>
             <a:endParaRPr lang="en-US" sz="2600" dirty="0"/>
           </a:p>
@@ -14845,6 +14849,10 @@
             <a:prstDash val="solid"/>
           </a:ln>
         </p:spPr>
+        <p:txBody>
+          <a:bodyPr/>
+          <a:p/>
+        </p:txBody>
       </p:sp>
       <p:sp>
         <p:nvSpPr>
@@ -14877,6 +14885,10 @@
             </a:outerShdw>
           </a:effectLst>
         </p:spPr>
+        <p:txBody>
+          <a:bodyPr/>
+          <a:p/>
+        </p:txBody>
       </p:sp>
       <p:sp>
         <p:nvSpPr>
@@ -14902,6 +14914,10 @@
             <a:prstDash val="solid"/>
           </a:ln>
         </p:spPr>
+        <p:txBody>
+          <a:bodyPr/>
+          <a:p/>
+        </p:txBody>
       </p:sp>
       <p:sp>
         <p:nvSpPr>
@@ -15012,6 +15028,10 @@
             </a:outerShdw>
           </a:effectLst>
         </p:spPr>
+        <p:txBody>
+          <a:bodyPr/>
+          <a:p/>
+        </p:txBody>
       </p:sp>
       <p:sp>
         <p:nvSpPr>
@@ -15037,6 +15057,10 @@
             <a:prstDash val="solid"/>
           </a:ln>
         </p:spPr>
+        <p:txBody>
+          <a:bodyPr/>
+          <a:p/>
+        </p:txBody>
       </p:sp>
       <p:sp>
         <p:nvSpPr>
@@ -15147,6 +15171,10 @@
             </a:outerShdw>
           </a:effectLst>
         </p:spPr>
+        <p:txBody>
+          <a:bodyPr/>
+          <a:p/>
+        </p:txBody>
       </p:sp>
       <p:sp>
         <p:nvSpPr>
@@ -15172,6 +15200,10 @@
             <a:prstDash val="solid"/>
           </a:ln>
         </p:spPr>
+        <p:txBody>
+          <a:bodyPr/>
+          <a:p/>
+        </p:txBody>
       </p:sp>
       <p:sp>
         <p:nvSpPr>
@@ -15206,7 +15238,7 @@
                 <a:ea typeface="Calibri" pitchFamily="34" charset="-122"/>
                 <a:cs typeface="Calibri" pitchFamily="34" charset="-120"/>
               </a:rPr>
-              <a:t>Calendar Sync</a:t>
+              <a:t>Calendar</a:t>
             </a:r>
             <a:endParaRPr lang="en-US" sz="1300" dirty="0"/>
           </a:p>
@@ -15245,7 +15277,7 @@
                 <a:ea typeface="Calibri" pitchFamily="34" charset="-122"/>
                 <a:cs typeface="Calibri" pitchFamily="34" charset="-120"/>
               </a:rPr>
-              <a:t>Google and Apple Calendar. Dos with dates appear automatically. Conflicts flagged with AI resolution suggestions.</a:t>
+              <a:t>Time-grid view with hour-snap drag. Recurring events on all their days. Import any Google Calendar. Bi-directional sync. Conflicts flagged with AI.</a:t>
             </a:r>
             <a:endParaRPr lang="en-US" sz="1050" dirty="0"/>
           </a:p>
@@ -15282,6 +15314,10 @@
             </a:outerShdw>
           </a:effectLst>
         </p:spPr>
+        <p:txBody>
+          <a:bodyPr/>
+          <a:p/>
+        </p:txBody>
       </p:sp>
       <p:sp>
         <p:nvSpPr>
@@ -15307,6 +15343,10 @@
             <a:prstDash val="solid"/>
           </a:ln>
         </p:spPr>
+        <p:txBody>
+          <a:bodyPr/>
+          <a:p/>
+        </p:txBody>
       </p:sp>
       <p:sp>
         <p:nvSpPr>
@@ -15417,6 +15457,10 @@
             </a:outerShdw>
           </a:effectLst>
         </p:spPr>
+        <p:txBody>
+          <a:bodyPr/>
+          <a:p/>
+        </p:txBody>
       </p:sp>
       <p:sp>
         <p:nvSpPr>
@@ -15442,6 +15486,10 @@
             <a:prstDash val="solid"/>
           </a:ln>
         </p:spPr>
+        <p:txBody>
+          <a:bodyPr/>
+          <a:p/>
+        </p:txBody>
       </p:sp>
       <p:sp>
         <p:nvSpPr>
@@ -15515,7 +15563,7 @@
                 <a:ea typeface="Calibri" pitchFamily="34" charset="-122"/>
                 <a:cs typeface="Calibri" pitchFamily="34" charset="-120"/>
               </a:rPr>
-              <a:t>Server-side cron reminders reach both devices. Quiet hours respected. Email + web push.</a:t>
+              <a:t>Smart routing - reminders reach the right person. Quiet hours respected. App-only or calendar-linked delivery. Email + web push.</a:t>
             </a:r>
             <a:endParaRPr lang="en-US" sz="1050" dirty="0"/>
           </a:p>
@@ -15552,6 +15600,10 @@
             </a:outerShdw>
           </a:effectLst>
         </p:spPr>
+        <p:txBody>
+          <a:bodyPr/>
+          <a:p/>
+        </p:txBody>
       </p:sp>
       <p:sp>
         <p:nvSpPr>
@@ -15577,6 +15629,10 @@
             <a:prstDash val="solid"/>
           </a:ln>
         </p:spPr>
+        <p:txBody>
+          <a:bodyPr/>
+          <a:p/>
+        </p:txBody>
       </p:sp>
       <p:sp>
         <p:nvSpPr>
@@ -15650,9 +15706,42 @@
                 <a:ea typeface="Calibri" pitchFamily="34" charset="-122"/>
                 <a:cs typeface="Calibri" pitchFamily="34" charset="-120"/>
               </a:rPr>
-              <a:t>Topic threads per card. Context stays with the item. No WhatsApp noise. Real-time sync.</a:t>
+              <a:t>Feed of cards with real messages, sorted by latest activity. Context stays with the card. Real-time sync.</a:t>
             </a:r>
             <a:endParaRPr lang="en-US" sz="1050" dirty="0"/>
+          </a:p>
+        </p:txBody>
+      </p:sp>
+      <p:sp>
+        <p:nvSpPr>
+          <p:cNvPr id="30" name="TextBox 29"/>
+          <p:cNvSpPr txBox="1"/>
+          <p:nvPr/>
+        </p:nvSpPr>
+        <p:spPr>
+          <a:xfrm>
+            <a:off x="457200" y="4695825"/>
+            <a:ext cx="8229600" cy="381000"/>
+          </a:xfrm>
+          <a:prstGeom prst="rect">
+            <a:avLst/>
+          </a:prstGeom>
+          <a:noFill/>
+        </p:spPr>
+        <p:txBody>
+          <a:bodyPr wrap="none">
+            <a:spAutoFit/>
+          </a:bodyPr>
+          <a:lstStyle/>
+          <a:p>
+            <a:r>
+              <a:rPr sz="850" b="0">
+                <a:solidFill>
+                  <a:srgbClr val="888888"/>
+                </a:solidFill>
+              </a:rPr>
+              <a:t>Also live: Shopping List (real-time sync)  ·  Custody Calendar (7-7 / 2-2-3 / 5-2 templates)  ·  PWA offline sync  ·  GDPR export</a:t>
+            </a:r>
           </a:p>
         </p:txBody>
       </p:sp>

</xml_diff>